<commit_message>
Minor updates to the original plan.
</commit_message>
<xml_diff>
--- a/Docs/Medallion_architecture_plan.pptx
+++ b/Docs/Medallion_architecture_plan.pptx
@@ -104,6 +104,11 @@
       </a:defRPr>
     </a:lvl9pPr>
   </p:defaultTextStyle>
+  <p:extLst>
+    <p:ext uri="{EFAFB233-063F-42B5-8137-9DF3F51BA10A}">
+      <p15:sldGuideLst xmlns:p15="http://schemas.microsoft.com/office/powerpoint/2012/main"/>
+    </p:ext>
+  </p:extLst>
 </p:presentation>
 </file>
 
@@ -256,7 +261,7 @@
           <a:p>
             <a:fld id="{88B0B717-D82B-43DE-9098-C0C2B650B5B6}" type="datetimeFigureOut">
               <a:rPr lang="en-FI" smtClean="0"/>
-              <a:t>29/06/2026</a:t>
+              <a:t>30/06/2026</a:t>
             </a:fld>
             <a:endParaRPr lang="en-FI"/>
           </a:p>
@@ -456,7 +461,7 @@
           <a:p>
             <a:fld id="{88B0B717-D82B-43DE-9098-C0C2B650B5B6}" type="datetimeFigureOut">
               <a:rPr lang="en-FI" smtClean="0"/>
-              <a:t>29/06/2026</a:t>
+              <a:t>30/06/2026</a:t>
             </a:fld>
             <a:endParaRPr lang="en-FI"/>
           </a:p>
@@ -666,7 +671,7 @@
           <a:p>
             <a:fld id="{88B0B717-D82B-43DE-9098-C0C2B650B5B6}" type="datetimeFigureOut">
               <a:rPr lang="en-FI" smtClean="0"/>
-              <a:t>29/06/2026</a:t>
+              <a:t>30/06/2026</a:t>
             </a:fld>
             <a:endParaRPr lang="en-FI"/>
           </a:p>
@@ -866,7 +871,7 @@
           <a:p>
             <a:fld id="{88B0B717-D82B-43DE-9098-C0C2B650B5B6}" type="datetimeFigureOut">
               <a:rPr lang="en-FI" smtClean="0"/>
-              <a:t>29/06/2026</a:t>
+              <a:t>30/06/2026</a:t>
             </a:fld>
             <a:endParaRPr lang="en-FI"/>
           </a:p>
@@ -1142,7 +1147,7 @@
           <a:p>
             <a:fld id="{88B0B717-D82B-43DE-9098-C0C2B650B5B6}" type="datetimeFigureOut">
               <a:rPr lang="en-FI" smtClean="0"/>
-              <a:t>29/06/2026</a:t>
+              <a:t>30/06/2026</a:t>
             </a:fld>
             <a:endParaRPr lang="en-FI"/>
           </a:p>
@@ -1410,7 +1415,7 @@
           <a:p>
             <a:fld id="{88B0B717-D82B-43DE-9098-C0C2B650B5B6}" type="datetimeFigureOut">
               <a:rPr lang="en-FI" smtClean="0"/>
-              <a:t>29/06/2026</a:t>
+              <a:t>30/06/2026</a:t>
             </a:fld>
             <a:endParaRPr lang="en-FI"/>
           </a:p>
@@ -1825,7 +1830,7 @@
           <a:p>
             <a:fld id="{88B0B717-D82B-43DE-9098-C0C2B650B5B6}" type="datetimeFigureOut">
               <a:rPr lang="en-FI" smtClean="0"/>
-              <a:t>29/06/2026</a:t>
+              <a:t>30/06/2026</a:t>
             </a:fld>
             <a:endParaRPr lang="en-FI"/>
           </a:p>
@@ -1967,7 +1972,7 @@
           <a:p>
             <a:fld id="{88B0B717-D82B-43DE-9098-C0C2B650B5B6}" type="datetimeFigureOut">
               <a:rPr lang="en-FI" smtClean="0"/>
-              <a:t>29/06/2026</a:t>
+              <a:t>30/06/2026</a:t>
             </a:fld>
             <a:endParaRPr lang="en-FI"/>
           </a:p>
@@ -2080,7 +2085,7 @@
           <a:p>
             <a:fld id="{88B0B717-D82B-43DE-9098-C0C2B650B5B6}" type="datetimeFigureOut">
               <a:rPr lang="en-FI" smtClean="0"/>
-              <a:t>29/06/2026</a:t>
+              <a:t>30/06/2026</a:t>
             </a:fld>
             <a:endParaRPr lang="en-FI"/>
           </a:p>
@@ -2393,7 +2398,7 @@
           <a:p>
             <a:fld id="{88B0B717-D82B-43DE-9098-C0C2B650B5B6}" type="datetimeFigureOut">
               <a:rPr lang="en-FI" smtClean="0"/>
-              <a:t>29/06/2026</a:t>
+              <a:t>30/06/2026</a:t>
             </a:fld>
             <a:endParaRPr lang="en-FI"/>
           </a:p>
@@ -2682,7 +2687,7 @@
           <a:p>
             <a:fld id="{88B0B717-D82B-43DE-9098-C0C2B650B5B6}" type="datetimeFigureOut">
               <a:rPr lang="en-FI" smtClean="0"/>
-              <a:t>29/06/2026</a:t>
+              <a:t>30/06/2026</a:t>
             </a:fld>
             <a:endParaRPr lang="en-FI"/>
           </a:p>
@@ -2925,7 +2930,7 @@
           <a:p>
             <a:fld id="{88B0B717-D82B-43DE-9098-C0C2B650B5B6}" type="datetimeFigureOut">
               <a:rPr lang="en-FI" smtClean="0"/>
-              <a:t>29/06/2026</a:t>
+              <a:t>30/06/2026</a:t>
             </a:fld>
             <a:endParaRPr lang="en-FI"/>
           </a:p>
@@ -4020,7 +4025,7 @@
         <p:spPr>
           <a:xfrm>
             <a:off x="4771090" y="2349931"/>
-            <a:ext cx="2582462" cy="3877985"/>
+            <a:ext cx="2582462" cy="4216539"/>
           </a:xfrm>
           <a:prstGeom prst="rect">
             <a:avLst/>
@@ -4105,6 +4110,27 @@
               <a:rPr lang="en-US" sz="1100" dirty="0"/>
               <a:t>silver_open_charge_SE.csv</a:t>
             </a:r>
+          </a:p>
+          <a:p>
+            <a:r>
+              <a:rPr lang="en-US" sz="1100" dirty="0">
+                <a:sym typeface="Wingdings" panose="05000000000000000000" pitchFamily="2" charset="2"/>
+              </a:rPr>
+              <a:t></a:t>
+            </a:r>
+            <a:br>
+              <a:rPr lang="en-US" sz="1100" dirty="0">
+                <a:sym typeface="Wingdings" panose="05000000000000000000" pitchFamily="2" charset="2"/>
+              </a:rPr>
+            </a:br>
+            <a:r>
+              <a:rPr lang="fi-FI" sz="1100" dirty="0"/>
+              <a:t>SQL Server </a:t>
+            </a:r>
+            <a:r>
+              <a:rPr lang="fi-FI" sz="1100" dirty="0" err="1"/>
+              <a:t>database</a:t>
+            </a:r>
             <a:endParaRPr lang="fi-FI" sz="1100" dirty="0"/>
           </a:p>
           <a:p>
@@ -4320,7 +4346,7 @@
         <p:spPr>
           <a:xfrm>
             <a:off x="7248046" y="2255211"/>
-            <a:ext cx="2432286" cy="3123932"/>
+            <a:ext cx="2432286" cy="3293209"/>
           </a:xfrm>
           <a:prstGeom prst="rect">
             <a:avLst/>
@@ -4444,31 +4470,23 @@
             </a:r>
             <a:r>
               <a:rPr lang="fi-FI" sz="1100" dirty="0" err="1"/>
-              <a:t>exact</a:t>
+              <a:t>FactEVCharging</a:t>
             </a:r>
             <a:r>
               <a:rPr lang="fi-FI" sz="1100" dirty="0"/>
-              <a:t> </a:t>
+              <a:t>, </a:t>
             </a:r>
             <a:r>
               <a:rPr lang="fi-FI" sz="1100" dirty="0" err="1"/>
-              <a:t>names</a:t>
+              <a:t>DimGeography</a:t>
             </a:r>
             <a:r>
               <a:rPr lang="fi-FI" sz="1100" dirty="0"/>
-              <a:t> to </a:t>
+              <a:t>, </a:t>
             </a:r>
             <a:r>
               <a:rPr lang="fi-FI" sz="1100" dirty="0" err="1"/>
-              <a:t>be</a:t>
-            </a:r>
-            <a:r>
-              <a:rPr lang="fi-FI" sz="1100" dirty="0"/>
-              <a:t> </a:t>
-            </a:r>
-            <a:r>
-              <a:rPr lang="fi-FI" sz="1100" dirty="0" err="1"/>
-              <a:t>decided</a:t>
+              <a:t>DimDate</a:t>
             </a:r>
             <a:r>
               <a:rPr lang="fi-FI" sz="1100" dirty="0"/>
@@ -4742,7 +4760,7 @@
           <a:p>
             <a:r>
               <a:rPr lang="fi-FI" sz="1200" dirty="0" err="1"/>
-              <a:t>Ev_registrations_charging_infra_dev.pbix</a:t>
+              <a:t>ev_registrations_charging_infra_dev.pbix</a:t>
             </a:r>
             <a:endParaRPr lang="fi-FI" sz="1200" dirty="0"/>
           </a:p>
@@ -4866,8 +4884,8 @@
         </p:nvSpPr>
         <p:spPr>
           <a:xfrm>
-            <a:off x="3792872" y="366187"/>
-            <a:ext cx="2163915" cy="430887"/>
+            <a:off x="3797066" y="151296"/>
+            <a:ext cx="2163915" cy="769441"/>
           </a:xfrm>
           <a:prstGeom prst="rect">
             <a:avLst/>
@@ -4901,6 +4919,47 @@
               <a:t>columns</a:t>
             </a:r>
             <a:endParaRPr lang="fi-FI" sz="1100" dirty="0"/>
+          </a:p>
+          <a:p>
+            <a:r>
+              <a:rPr lang="fi-FI" sz="1100" dirty="0" err="1"/>
+              <a:t>Remove</a:t>
+            </a:r>
+            <a:r>
+              <a:rPr lang="fi-FI" sz="1100" dirty="0"/>
+              <a:t> </a:t>
+            </a:r>
+            <a:r>
+              <a:rPr lang="fi-FI" sz="1100" dirty="0" err="1"/>
+              <a:t>rows</a:t>
+            </a:r>
+            <a:endParaRPr lang="fi-FI" sz="1100" dirty="0"/>
+          </a:p>
+          <a:p>
+            <a:r>
+              <a:rPr lang="fi-FI" sz="1100" dirty="0" err="1"/>
+              <a:t>Add</a:t>
+            </a:r>
+            <a:r>
+              <a:rPr lang="fi-FI" sz="1100" dirty="0"/>
+              <a:t> </a:t>
+            </a:r>
+            <a:r>
+              <a:rPr lang="fi-FI" sz="1100" dirty="0" err="1"/>
+              <a:t>columns</a:t>
+            </a:r>
+            <a:r>
+              <a:rPr lang="fi-FI" sz="1100" dirty="0"/>
+              <a:t> (”</a:t>
+            </a:r>
+            <a:r>
+              <a:rPr lang="fi-FI" sz="1100" dirty="0" err="1"/>
+              <a:t>region</a:t>
+            </a:r>
+            <a:r>
+              <a:rPr lang="fi-FI" sz="1100" dirty="0"/>
+              <a:t>”)</a:t>
+            </a:r>
           </a:p>
           <a:p>
             <a:r>

</xml_diff>

<commit_message>
Updated output file names for silver level in the medallion architecture plan PowerPoint.
</commit_message>
<xml_diff>
--- a/Docs/Medallion_architecture_plan.pptx
+++ b/Docs/Medallion_architecture_plan.pptx
@@ -261,7 +261,7 @@
           <a:p>
             <a:fld id="{88B0B717-D82B-43DE-9098-C0C2B650B5B6}" type="datetimeFigureOut">
               <a:rPr lang="en-FI" smtClean="0"/>
-              <a:t>30/06/2026</a:t>
+              <a:t>01/07/2026</a:t>
             </a:fld>
             <a:endParaRPr lang="en-FI"/>
           </a:p>
@@ -461,7 +461,7 @@
           <a:p>
             <a:fld id="{88B0B717-D82B-43DE-9098-C0C2B650B5B6}" type="datetimeFigureOut">
               <a:rPr lang="en-FI" smtClean="0"/>
-              <a:t>30/06/2026</a:t>
+              <a:t>01/07/2026</a:t>
             </a:fld>
             <a:endParaRPr lang="en-FI"/>
           </a:p>
@@ -671,7 +671,7 @@
           <a:p>
             <a:fld id="{88B0B717-D82B-43DE-9098-C0C2B650B5B6}" type="datetimeFigureOut">
               <a:rPr lang="en-FI" smtClean="0"/>
-              <a:t>30/06/2026</a:t>
+              <a:t>01/07/2026</a:t>
             </a:fld>
             <a:endParaRPr lang="en-FI"/>
           </a:p>
@@ -871,7 +871,7 @@
           <a:p>
             <a:fld id="{88B0B717-D82B-43DE-9098-C0C2B650B5B6}" type="datetimeFigureOut">
               <a:rPr lang="en-FI" smtClean="0"/>
-              <a:t>30/06/2026</a:t>
+              <a:t>01/07/2026</a:t>
             </a:fld>
             <a:endParaRPr lang="en-FI"/>
           </a:p>
@@ -1147,7 +1147,7 @@
           <a:p>
             <a:fld id="{88B0B717-D82B-43DE-9098-C0C2B650B5B6}" type="datetimeFigureOut">
               <a:rPr lang="en-FI" smtClean="0"/>
-              <a:t>30/06/2026</a:t>
+              <a:t>01/07/2026</a:t>
             </a:fld>
             <a:endParaRPr lang="en-FI"/>
           </a:p>
@@ -1415,7 +1415,7 @@
           <a:p>
             <a:fld id="{88B0B717-D82B-43DE-9098-C0C2B650B5B6}" type="datetimeFigureOut">
               <a:rPr lang="en-FI" smtClean="0"/>
-              <a:t>30/06/2026</a:t>
+              <a:t>01/07/2026</a:t>
             </a:fld>
             <a:endParaRPr lang="en-FI"/>
           </a:p>
@@ -1830,7 +1830,7 @@
           <a:p>
             <a:fld id="{88B0B717-D82B-43DE-9098-C0C2B650B5B6}" type="datetimeFigureOut">
               <a:rPr lang="en-FI" smtClean="0"/>
-              <a:t>30/06/2026</a:t>
+              <a:t>01/07/2026</a:t>
             </a:fld>
             <a:endParaRPr lang="en-FI"/>
           </a:p>
@@ -1972,7 +1972,7 @@
           <a:p>
             <a:fld id="{88B0B717-D82B-43DE-9098-C0C2B650B5B6}" type="datetimeFigureOut">
               <a:rPr lang="en-FI" smtClean="0"/>
-              <a:t>30/06/2026</a:t>
+              <a:t>01/07/2026</a:t>
             </a:fld>
             <a:endParaRPr lang="en-FI"/>
           </a:p>
@@ -2085,7 +2085,7 @@
           <a:p>
             <a:fld id="{88B0B717-D82B-43DE-9098-C0C2B650B5B6}" type="datetimeFigureOut">
               <a:rPr lang="en-FI" smtClean="0"/>
-              <a:t>30/06/2026</a:t>
+              <a:t>01/07/2026</a:t>
             </a:fld>
             <a:endParaRPr lang="en-FI"/>
           </a:p>
@@ -2398,7 +2398,7 @@
           <a:p>
             <a:fld id="{88B0B717-D82B-43DE-9098-C0C2B650B5B6}" type="datetimeFigureOut">
               <a:rPr lang="en-FI" smtClean="0"/>
-              <a:t>30/06/2026</a:t>
+              <a:t>01/07/2026</a:t>
             </a:fld>
             <a:endParaRPr lang="en-FI"/>
           </a:p>
@@ -2687,7 +2687,7 @@
           <a:p>
             <a:fld id="{88B0B717-D82B-43DE-9098-C0C2B650B5B6}" type="datetimeFigureOut">
               <a:rPr lang="en-FI" smtClean="0"/>
-              <a:t>30/06/2026</a:t>
+              <a:t>01/07/2026</a:t>
             </a:fld>
             <a:endParaRPr lang="en-FI"/>
           </a:p>
@@ -2930,7 +2930,7 @@
           <a:p>
             <a:fld id="{88B0B717-D82B-43DE-9098-C0C2B650B5B6}" type="datetimeFigureOut">
               <a:rPr lang="en-FI" smtClean="0"/>
-              <a:t>30/06/2026</a:t>
+              <a:t>01/07/2026</a:t>
             </a:fld>
             <a:endParaRPr lang="en-FI"/>
           </a:p>
@@ -4025,7 +4025,7 @@
         <p:spPr>
           <a:xfrm>
             <a:off x="4771090" y="2349931"/>
-            <a:ext cx="2582462" cy="4216539"/>
+            <a:ext cx="2615416" cy="4570477"/>
           </a:xfrm>
           <a:prstGeom prst="rect">
             <a:avLst/>
@@ -4090,7 +4090,20 @@
           <a:p>
             <a:r>
               <a:rPr lang="en-US" sz="1100" dirty="0"/>
-              <a:t>silver_new_car_registrations_FI.csv</a:t>
+              <a:t>silver_car_registrations_finland.csv</a:t>
+            </a:r>
+            <a:br>
+              <a:rPr lang="en-US" sz="1100" dirty="0"/>
+            </a:br>
+            <a:r>
+              <a:rPr lang="en-US" sz="800" dirty="0"/>
+              <a:t>silver_new_car_registrations_totals_lookup_FI.csv</a:t>
+            </a:r>
+          </a:p>
+          <a:p>
+            <a:r>
+              <a:rPr lang="en-US" sz="800" dirty="0"/>
+              <a:t>silver_new_car_registrations_totals_lookup_SE.csv</a:t>
             </a:r>
           </a:p>
           <a:p>
@@ -4102,13 +4115,25 @@
           <a:p>
             <a:r>
               <a:rPr lang="en-US" sz="1100" dirty="0"/>
-              <a:t>silver_open_charge_FI.csv</a:t>
+              <a:t>silver_ev_charging_stations_FI.csv</a:t>
+            </a:r>
+          </a:p>
+          <a:p>
+            <a:r>
+              <a:rPr lang="en-US" sz="900" dirty="0"/>
+              <a:t>REJECTED_silver_ev_charging_stations_FI.csv</a:t>
             </a:r>
           </a:p>
           <a:p>
             <a:r>
               <a:rPr lang="en-US" sz="1100" dirty="0"/>
-              <a:t>silver_open_charge_SE.csv</a:t>
+              <a:t>silver_ev_charging_stations_SE.csv</a:t>
+            </a:r>
+          </a:p>
+          <a:p>
+            <a:r>
+              <a:rPr lang="en-US" sz="900" dirty="0"/>
+              <a:t>REJECTED_silver_ev_charging_stations_SE.csv</a:t>
             </a:r>
           </a:p>
           <a:p>
@@ -4131,6 +4156,22 @@
               <a:rPr lang="fi-FI" sz="1100" dirty="0" err="1"/>
               <a:t>database</a:t>
             </a:r>
+            <a:r>
+              <a:rPr lang="fi-FI" sz="1100" dirty="0"/>
+              <a:t> </a:t>
+            </a:r>
+            <a:r>
+              <a:rPr lang="fi-FI" sz="1100" dirty="0" err="1"/>
+              <a:t>de_db</a:t>
+            </a:r>
+            <a:r>
+              <a:rPr lang="fi-FI" sz="1100" dirty="0"/>
+              <a:t> on </a:t>
+            </a:r>
+            <a:r>
+              <a:rPr lang="fi-FI" sz="1100" dirty="0" err="1"/>
+              <a:t>Azure</a:t>
+            </a:r>
             <a:endParaRPr lang="fi-FI" sz="1100" dirty="0"/>
           </a:p>
           <a:p>
@@ -4181,9 +4222,6 @@
             </a:r>
           </a:p>
           <a:p>
-            <a:endParaRPr lang="fi-FI" sz="1100" dirty="0"/>
-          </a:p>
-          <a:p>
             <a:r>
               <a:rPr lang="fi-FI" sz="1100" dirty="0"/>
               <a:t>No </a:t>
@@ -4309,9 +4347,6 @@
               <a:rPr lang="fi-FI" sz="1100" dirty="0" err="1"/>
               <a:t>values</a:t>
             </a:r>
-            <a:endParaRPr lang="fi-FI" sz="1100" dirty="0"/>
-          </a:p>
-          <a:p>
             <a:endParaRPr lang="fi-FI" sz="1100" dirty="0"/>
           </a:p>
           <a:p>

</xml_diff>